<commit_message>
added comments on covers lide
</commit_message>
<xml_diff>
--- a/flask_app/assets/cover.slides.pptx
+++ b/flask_app/assets/cover.slides.pptx
@@ -209,7 +209,7 @@
           <a:p>
             <a:fld id="{C8E227CC-8F40-43A0-A784-1E77C9226FBC}" type="datetimeFigureOut">
               <a:rPr lang="fr-FR" smtClean="0"/>
-              <a:t>15/05/2025</a:t>
+              <a:t>19/05/2025</a:t>
             </a:fld>
             <a:endParaRPr lang="fr-FR"/>
           </a:p>
@@ -520,7 +520,911 @@
           <a:bodyPr/>
           <a:lstStyle/>
           <a:p>
+            <a:pPr>
+              <a:buSzPts val="1400"/>
+            </a:pPr>
+            <a:r>
+              <a:rPr lang="fr-FR" b="1" i="0" u="none" strike="noStrike" dirty="0">
+                <a:solidFill>
+                  <a:schemeClr val="dk1"/>
+                </a:solidFill>
+                <a:latin typeface="Arial"/>
+                <a:ea typeface="Arial"/>
+                <a:cs typeface="Arial"/>
+                <a:sym typeface="Arial"/>
+              </a:rPr>
+              <a:t>Points clés :</a:t>
+            </a:r>
+            <a:endParaRPr lang="fr-FR" i="1" dirty="0">
+              <a:solidFill>
+                <a:srgbClr val="595959"/>
+              </a:solidFill>
+            </a:endParaRPr>
+          </a:p>
+          <a:p>
+            <a:pPr marL="171450" lvl="0" indent="-171450" algn="l" rtl="0">
+              <a:spcBef>
+                <a:spcPts val="0"/>
+              </a:spcBef>
+              <a:spcAft>
+                <a:spcPts val="0"/>
+              </a:spcAft>
+              <a:buClr>
+                <a:srgbClr val="595959"/>
+              </a:buClr>
+              <a:buSzPts val="900"/>
+              <a:buFont typeface="Arial"/>
+              <a:buChar char="•"/>
+            </a:pPr>
+            <a:r>
+              <a:rPr lang="fr-FR" i="1" dirty="0">
+                <a:solidFill>
+                  <a:srgbClr val="595959"/>
+                </a:solidFill>
+              </a:rPr>
+              <a:t>Présenter les conférenciers</a:t>
+            </a:r>
             <a:endParaRPr lang="fr-FR" dirty="0"/>
+          </a:p>
+          <a:p>
+            <a:pPr marL="0" lvl="0" indent="0" algn="l" rtl="0">
+              <a:spcBef>
+                <a:spcPts val="0"/>
+              </a:spcBef>
+              <a:spcAft>
+                <a:spcPts val="0"/>
+              </a:spcAft>
+              <a:buClr>
+                <a:srgbClr val="595959"/>
+              </a:buClr>
+              <a:buSzPts val="900"/>
+              <a:buFont typeface="Arial"/>
+              <a:buNone/>
+            </a:pPr>
+            <a:r>
+              <a:rPr lang="fr-FR" dirty="0">
+                <a:solidFill>
+                  <a:srgbClr val="595959"/>
+                </a:solidFill>
+              </a:rPr>
+              <a:t>Nous sommes des bénévoles soutenant l’association The Shift Project, un laboratoire d’idées qui milite pour la décarbonation de l’économie.</a:t>
+            </a:r>
+            <a:endParaRPr lang="fr-FR" i="0" dirty="0">
+              <a:solidFill>
+                <a:srgbClr val="595959"/>
+              </a:solidFill>
+            </a:endParaRPr>
+          </a:p>
+          <a:p>
+            <a:pPr marL="171450" lvl="0" indent="-171450" algn="l" rtl="0">
+              <a:spcBef>
+                <a:spcPts val="0"/>
+              </a:spcBef>
+              <a:spcAft>
+                <a:spcPts val="0"/>
+              </a:spcAft>
+              <a:buClr>
+                <a:srgbClr val="595959"/>
+              </a:buClr>
+              <a:buSzPts val="900"/>
+              <a:buFont typeface="Arial"/>
+              <a:buChar char="•"/>
+            </a:pPr>
+            <a:r>
+              <a:rPr lang="fr-FR" i="1" dirty="0">
+                <a:solidFill>
+                  <a:srgbClr val="595959"/>
+                </a:solidFill>
+              </a:rPr>
+              <a:t>Remerciements (demander </a:t>
+            </a:r>
+            <a:r>
+              <a:rPr lang="fr-FR" i="1" u="sng" dirty="0">
+                <a:solidFill>
+                  <a:srgbClr val="595959"/>
+                </a:solidFill>
+              </a:rPr>
+              <a:t>avant</a:t>
+            </a:r>
+            <a:r>
+              <a:rPr lang="fr-FR" i="1" dirty="0">
+                <a:solidFill>
+                  <a:srgbClr val="595959"/>
+                </a:solidFill>
+              </a:rPr>
+              <a:t> la conférence à l’organisateur </a:t>
+            </a:r>
+            <a:r>
+              <a:rPr lang="fr-FR" i="1" u="sng" dirty="0">
+                <a:solidFill>
+                  <a:srgbClr val="595959"/>
+                </a:solidFill>
+              </a:rPr>
+              <a:t>qui il faut remercier</a:t>
+            </a:r>
+            <a:r>
+              <a:rPr lang="fr-FR" i="1" u="none" dirty="0">
+                <a:solidFill>
+                  <a:srgbClr val="595959"/>
+                </a:solidFill>
+              </a:rPr>
+              <a:t> </a:t>
+            </a:r>
+            <a:r>
+              <a:rPr lang="fr-FR" i="1" dirty="0">
+                <a:solidFill>
+                  <a:srgbClr val="595959"/>
+                </a:solidFill>
+              </a:rPr>
+              <a:t>: lieu d’accueil, entité organisatrice, etc.)</a:t>
+            </a:r>
+            <a:endParaRPr lang="fr-FR" dirty="0"/>
+          </a:p>
+          <a:p>
+            <a:pPr marL="171450" lvl="0" indent="-171450" algn="l" rtl="0">
+              <a:spcBef>
+                <a:spcPts val="0"/>
+              </a:spcBef>
+              <a:spcAft>
+                <a:spcPts val="0"/>
+              </a:spcAft>
+              <a:buClr>
+                <a:srgbClr val="595959"/>
+              </a:buClr>
+              <a:buSzPts val="900"/>
+              <a:buFont typeface="Arial"/>
+              <a:buChar char="•"/>
+            </a:pPr>
+            <a:r>
+              <a:rPr lang="fr-FR" i="1" dirty="0">
+                <a:solidFill>
+                  <a:srgbClr val="595959"/>
+                </a:solidFill>
+              </a:rPr>
+              <a:t>Annoncer la durée de la conférence et qu’il y aura des questions-réponses ensuite (ou pas)</a:t>
+            </a:r>
+            <a:endParaRPr lang="fr-FR" dirty="0"/>
+          </a:p>
+          <a:p>
+            <a:pPr marL="171450" lvl="0" indent="-171450" algn="l" rtl="0">
+              <a:spcBef>
+                <a:spcPts val="0"/>
+              </a:spcBef>
+              <a:spcAft>
+                <a:spcPts val="0"/>
+              </a:spcAft>
+              <a:buClr>
+                <a:srgbClr val="595959"/>
+              </a:buClr>
+              <a:buSzPts val="900"/>
+              <a:buFont typeface="Arial"/>
+              <a:buChar char="•"/>
+            </a:pPr>
+            <a:r>
+              <a:rPr lang="fr-FR" i="1" dirty="0">
+                <a:solidFill>
+                  <a:srgbClr val="595959"/>
+                </a:solidFill>
+              </a:rPr>
+              <a:t>[Option: 1</a:t>
+            </a:r>
+            <a:r>
+              <a:rPr lang="fr-FR" i="1" baseline="30000" dirty="0">
+                <a:solidFill>
+                  <a:srgbClr val="595959"/>
+                </a:solidFill>
+              </a:rPr>
+              <a:t>ère</a:t>
+            </a:r>
+            <a:r>
+              <a:rPr lang="fr-FR" i="1" dirty="0">
+                <a:solidFill>
+                  <a:srgbClr val="595959"/>
+                </a:solidFill>
+              </a:rPr>
+              <a:t> interaction immédiate avec le public</a:t>
+            </a:r>
+            <a:r>
+              <a:rPr lang="fr-FR" i="0" dirty="0">
+                <a:solidFill>
+                  <a:srgbClr val="595959"/>
+                </a:solidFill>
+              </a:rPr>
+              <a:t> « est-ce qu’il y a des sujets que vous souhaitez qu’on aborde / est-ce que vous avez des attentes particulières vis-à-vis de cette conférence ? » </a:t>
+            </a:r>
+            <a:r>
+              <a:rPr lang="fr-FR" i="1" dirty="0">
+                <a:solidFill>
+                  <a:srgbClr val="595959"/>
+                </a:solidFill>
+              </a:rPr>
+              <a:t>Dans ce cas, noter les réponses, réagir éventuellement très brièvement dessus, notamment en annonçant ce qui ne sera pas traité et devra donc l’être dans les questions-réponses]</a:t>
+            </a:r>
+          </a:p>
+          <a:p>
+            <a:pPr marL="171450" lvl="0" indent="-171450" algn="l" rtl="0">
+              <a:spcBef>
+                <a:spcPts val="0"/>
+              </a:spcBef>
+              <a:spcAft>
+                <a:spcPts val="0"/>
+              </a:spcAft>
+              <a:buClr>
+                <a:srgbClr val="595959"/>
+              </a:buClr>
+              <a:buSzPts val="900"/>
+              <a:buFont typeface="Arial"/>
+              <a:buChar char="•"/>
+            </a:pPr>
+            <a:endParaRPr lang="fr-FR" dirty="0"/>
+          </a:p>
+          <a:p>
+            <a:pPr marL="0" lvl="0" indent="0" algn="l" rtl="0">
+              <a:spcBef>
+                <a:spcPts val="0"/>
+              </a:spcBef>
+              <a:spcAft>
+                <a:spcPts val="0"/>
+              </a:spcAft>
+              <a:buClr>
+                <a:srgbClr val="595959"/>
+              </a:buClr>
+              <a:buSzPts val="900"/>
+              <a:buFont typeface="Arial"/>
+              <a:buNone/>
+            </a:pPr>
+            <a:r>
+              <a:rPr lang="fr-FR" i="0" u="none" dirty="0">
+                <a:solidFill>
+                  <a:srgbClr val="595959"/>
+                </a:solidFill>
+              </a:rPr>
+              <a:t>Synthèse des éléments à personnaliser / préparer avant chaque conférence</a:t>
+            </a:r>
+          </a:p>
+          <a:p>
+            <a:pPr marL="171450" lvl="0" indent="-114300" algn="l" rtl="0">
+              <a:spcBef>
+                <a:spcPts val="0"/>
+              </a:spcBef>
+              <a:spcAft>
+                <a:spcPts val="0"/>
+              </a:spcAft>
+              <a:buClr>
+                <a:srgbClr val="595959"/>
+              </a:buClr>
+              <a:buSzPts val="900"/>
+              <a:buFont typeface="Arial"/>
+              <a:buNone/>
+            </a:pPr>
+            <a:endParaRPr lang="fr-FR" i="0" u="none" dirty="0">
+              <a:solidFill>
+                <a:srgbClr val="595959"/>
+              </a:solidFill>
+            </a:endParaRPr>
+          </a:p>
+          <a:p>
+            <a:pPr marL="171450" lvl="0" indent="-171450" algn="l" rtl="0">
+              <a:spcBef>
+                <a:spcPts val="0"/>
+              </a:spcBef>
+              <a:spcAft>
+                <a:spcPts val="0"/>
+              </a:spcAft>
+              <a:buClr>
+                <a:srgbClr val="595959"/>
+              </a:buClr>
+              <a:buSzPts val="900"/>
+              <a:buFont typeface="Arial"/>
+              <a:buChar char="•"/>
+            </a:pPr>
+            <a:r>
+              <a:rPr lang="fr-FR" i="0" u="none" dirty="0">
+                <a:solidFill>
+                  <a:srgbClr val="595959"/>
+                </a:solidFill>
+              </a:rPr>
+              <a:t>Prépa logistique:</a:t>
+            </a:r>
+            <a:endParaRPr lang="fr-FR" u="none" dirty="0"/>
+          </a:p>
+          <a:p>
+            <a:pPr marL="628650" lvl="1" indent="-171450" algn="l" rtl="0">
+              <a:spcBef>
+                <a:spcPts val="0"/>
+              </a:spcBef>
+              <a:spcAft>
+                <a:spcPts val="0"/>
+              </a:spcAft>
+              <a:buClr>
+                <a:srgbClr val="595959"/>
+              </a:buClr>
+              <a:buSzPts val="900"/>
+              <a:buFont typeface="Arial"/>
+              <a:buChar char="•"/>
+            </a:pPr>
+            <a:r>
+              <a:rPr lang="fr-FR" i="0" u="none" dirty="0">
+                <a:solidFill>
+                  <a:srgbClr val="595959"/>
+                </a:solidFill>
+              </a:rPr>
+              <a:t>Pour l’introduction de la conférence, qui faut-il remercier (organisateurs, partenaires, etc.) ? Pour les éventuels élus ou VIP présents, on peut simplement les remercier de leur présence.</a:t>
+            </a:r>
+            <a:endParaRPr lang="fr-FR" u="none" dirty="0"/>
+          </a:p>
+          <a:p>
+            <a:pPr marL="628650" lvl="1" indent="-171450" algn="l" rtl="0">
+              <a:spcBef>
+                <a:spcPts val="0"/>
+              </a:spcBef>
+              <a:spcAft>
+                <a:spcPts val="0"/>
+              </a:spcAft>
+              <a:buClr>
+                <a:srgbClr val="595959"/>
+              </a:buClr>
+              <a:buSzPts val="900"/>
+              <a:buFont typeface="Arial"/>
+              <a:buChar char="•"/>
+            </a:pPr>
+            <a:r>
+              <a:rPr lang="fr-FR" i="0" u="none" dirty="0">
+                <a:solidFill>
+                  <a:srgbClr val="595959"/>
+                </a:solidFill>
+              </a:rPr>
+              <a:t>Horaires précis de la conférence, notamment: </a:t>
+            </a:r>
+            <a:endParaRPr lang="fr-FR" u="none" dirty="0"/>
+          </a:p>
+          <a:p>
+            <a:pPr marL="1085850" lvl="2" indent="-171450" algn="l" rtl="0">
+              <a:spcBef>
+                <a:spcPts val="0"/>
+              </a:spcBef>
+              <a:spcAft>
+                <a:spcPts val="0"/>
+              </a:spcAft>
+              <a:buClr>
+                <a:srgbClr val="595959"/>
+              </a:buClr>
+              <a:buSzPts val="900"/>
+              <a:buFont typeface="Arial"/>
+              <a:buChar char="•"/>
+            </a:pPr>
+            <a:r>
+              <a:rPr lang="fr-FR" i="0" u="none" dirty="0">
+                <a:solidFill>
+                  <a:srgbClr val="595959"/>
+                </a:solidFill>
+              </a:rPr>
+              <a:t>La salle sera-t-elle disponible avant la conférence, et si oui combien de temps avant ?</a:t>
+            </a:r>
+            <a:endParaRPr lang="fr-FR" u="none" dirty="0"/>
+          </a:p>
+          <a:p>
+            <a:pPr marL="1085850" lvl="2" indent="-171450" algn="l" rtl="0">
+              <a:spcBef>
+                <a:spcPts val="0"/>
+              </a:spcBef>
+              <a:spcAft>
+                <a:spcPts val="0"/>
+              </a:spcAft>
+              <a:buClr>
+                <a:srgbClr val="595959"/>
+              </a:buClr>
+              <a:buSzPts val="900"/>
+              <a:buFont typeface="Arial"/>
+              <a:buChar char="•"/>
+            </a:pPr>
+            <a:r>
+              <a:rPr lang="fr-FR" i="0" u="none" dirty="0">
+                <a:solidFill>
+                  <a:srgbClr val="595959"/>
+                </a:solidFill>
+              </a:rPr>
+              <a:t>Y a-t-il une heure à laquelle il faut avoir fini / évacué les lieux ?</a:t>
+            </a:r>
+            <a:endParaRPr lang="fr-FR" u="none" dirty="0"/>
+          </a:p>
+          <a:p>
+            <a:pPr marL="628650" lvl="1" indent="-171450" algn="l" rtl="0">
+              <a:spcBef>
+                <a:spcPts val="0"/>
+              </a:spcBef>
+              <a:spcAft>
+                <a:spcPts val="0"/>
+              </a:spcAft>
+              <a:buClr>
+                <a:srgbClr val="595959"/>
+              </a:buClr>
+              <a:buSzPts val="900"/>
+              <a:buFont typeface="Arial"/>
+              <a:buChar char="•"/>
+            </a:pPr>
+            <a:r>
+              <a:rPr lang="fr-FR" i="0" u="none" dirty="0">
+                <a:solidFill>
+                  <a:srgbClr val="595959"/>
+                </a:solidFill>
+              </a:rPr>
+              <a:t>Disposition de la salle: </a:t>
+            </a:r>
+            <a:endParaRPr lang="fr-FR" u="none" dirty="0"/>
+          </a:p>
+          <a:p>
+            <a:pPr marL="1085850" lvl="2" indent="-171450" algn="l" rtl="0">
+              <a:spcBef>
+                <a:spcPts val="0"/>
+              </a:spcBef>
+              <a:spcAft>
+                <a:spcPts val="0"/>
+              </a:spcAft>
+              <a:buClr>
+                <a:srgbClr val="595959"/>
+              </a:buClr>
+              <a:buSzPts val="900"/>
+              <a:buFont typeface="Arial"/>
+              <a:buChar char="•"/>
+            </a:pPr>
+            <a:r>
+              <a:rPr lang="fr-FR" i="0" u="none" dirty="0">
+                <a:solidFill>
+                  <a:srgbClr val="595959"/>
+                </a:solidFill>
+              </a:rPr>
+              <a:t>Quelle est la jauge de la salle ? (utile pour la communication notamment) </a:t>
+            </a:r>
+            <a:endParaRPr lang="fr-FR" u="none" dirty="0"/>
+          </a:p>
+          <a:p>
+            <a:pPr marL="1085850" lvl="2" indent="-171450" algn="l" rtl="0">
+              <a:spcBef>
+                <a:spcPts val="0"/>
+              </a:spcBef>
+              <a:spcAft>
+                <a:spcPts val="0"/>
+              </a:spcAft>
+              <a:buClr>
+                <a:srgbClr val="595959"/>
+              </a:buClr>
+              <a:buSzPts val="900"/>
+              <a:buFont typeface="Arial"/>
+              <a:buChar char="•"/>
+            </a:pPr>
+            <a:r>
+              <a:rPr lang="fr-FR" i="0" u="none" dirty="0">
+                <a:solidFill>
+                  <a:srgbClr val="595959"/>
+                </a:solidFill>
+              </a:rPr>
+              <a:t>Les chaises seront-elles installées avant la conférence, ou faudra-t-il le faire en arrivant ?</a:t>
+            </a:r>
+            <a:endParaRPr lang="fr-FR" u="none" dirty="0"/>
+          </a:p>
+          <a:p>
+            <a:pPr marL="1085850" lvl="2" indent="-171450" algn="l" rtl="0">
+              <a:spcBef>
+                <a:spcPts val="0"/>
+              </a:spcBef>
+              <a:spcAft>
+                <a:spcPts val="0"/>
+              </a:spcAft>
+              <a:buClr>
+                <a:srgbClr val="595959"/>
+              </a:buClr>
+              <a:buSzPts val="900"/>
+              <a:buFont typeface="Arial"/>
+              <a:buChar char="•"/>
+            </a:pPr>
+            <a:r>
+              <a:rPr lang="fr-FR" i="0" u="none" dirty="0">
+                <a:solidFill>
+                  <a:srgbClr val="595959"/>
+                </a:solidFill>
+              </a:rPr>
+              <a:t>Y aura-t-il un paperboard, avec stylos-feutres épais ?</a:t>
+            </a:r>
+            <a:endParaRPr lang="fr-FR" u="none" dirty="0"/>
+          </a:p>
+          <a:p>
+            <a:pPr marL="1085850" lvl="2" indent="-171450" algn="l" rtl="0">
+              <a:spcBef>
+                <a:spcPts val="0"/>
+              </a:spcBef>
+              <a:spcAft>
+                <a:spcPts val="0"/>
+              </a:spcAft>
+              <a:buClr>
+                <a:srgbClr val="595959"/>
+              </a:buClr>
+              <a:buSzPts val="900"/>
+              <a:buFont typeface="Arial"/>
+              <a:buChar char="•"/>
+            </a:pPr>
+            <a:r>
+              <a:rPr lang="fr-FR" i="0" u="none" dirty="0">
+                <a:solidFill>
+                  <a:srgbClr val="595959"/>
+                </a:solidFill>
+              </a:rPr>
+              <a:t>Y a-t-il une horloge visible depuis l’endroit où seront les conférenciers ?</a:t>
+            </a:r>
+            <a:endParaRPr lang="fr-FR" u="none" dirty="0"/>
+          </a:p>
+          <a:p>
+            <a:pPr marL="1085850" lvl="2" indent="-171450" algn="l" rtl="0">
+              <a:spcBef>
+                <a:spcPts val="0"/>
+              </a:spcBef>
+              <a:spcAft>
+                <a:spcPts val="0"/>
+              </a:spcAft>
+              <a:buClr>
+                <a:srgbClr val="595959"/>
+              </a:buClr>
+              <a:buSzPts val="900"/>
+              <a:buFont typeface="Arial"/>
+              <a:buChar char="•"/>
+            </a:pPr>
+            <a:r>
+              <a:rPr lang="fr-FR" i="0" u="none" dirty="0">
+                <a:solidFill>
+                  <a:srgbClr val="595959"/>
+                </a:solidFill>
+              </a:rPr>
+              <a:t>Quelle devrait être la luminosité de la salle pendant la conférence (pour la visibilité des supports projetés et pour la captation vidéos éventuelle)</a:t>
+            </a:r>
+            <a:endParaRPr lang="fr-FR" u="none" dirty="0"/>
+          </a:p>
+          <a:p>
+            <a:pPr marL="1085850" lvl="2" indent="-171450" algn="l" rtl="0">
+              <a:spcBef>
+                <a:spcPts val="0"/>
+              </a:spcBef>
+              <a:spcAft>
+                <a:spcPts val="0"/>
+              </a:spcAft>
+              <a:buClr>
+                <a:srgbClr val="595959"/>
+              </a:buClr>
+              <a:buSzPts val="900"/>
+              <a:buFont typeface="Arial"/>
+              <a:buChar char="•"/>
+            </a:pPr>
+            <a:r>
+              <a:rPr lang="fr-FR" i="0" u="none" dirty="0">
+                <a:solidFill>
+                  <a:srgbClr val="595959"/>
+                </a:solidFill>
+              </a:rPr>
+              <a:t>Penser à prendre un pointeur (compatible avec le PC utilisé !)</a:t>
+            </a:r>
+            <a:endParaRPr lang="fr-FR" u="none" dirty="0"/>
+          </a:p>
+          <a:p>
+            <a:pPr marL="628650" lvl="1" indent="-171450" algn="l" rtl="0">
+              <a:spcBef>
+                <a:spcPts val="0"/>
+              </a:spcBef>
+              <a:spcAft>
+                <a:spcPts val="0"/>
+              </a:spcAft>
+              <a:buClr>
+                <a:srgbClr val="595959"/>
+              </a:buClr>
+              <a:buSzPts val="900"/>
+              <a:buFont typeface="Arial"/>
+              <a:buChar char="•"/>
+            </a:pPr>
+            <a:r>
+              <a:rPr lang="fr-FR" i="0" u="none" dirty="0">
+                <a:solidFill>
+                  <a:srgbClr val="595959"/>
+                </a:solidFill>
+              </a:rPr>
+              <a:t>Projection des supports:</a:t>
+            </a:r>
+            <a:endParaRPr lang="fr-FR" u="none" dirty="0"/>
+          </a:p>
+          <a:p>
+            <a:pPr marL="1085850" lvl="2" indent="-171450" algn="l" rtl="0">
+              <a:spcBef>
+                <a:spcPts val="0"/>
+              </a:spcBef>
+              <a:spcAft>
+                <a:spcPts val="0"/>
+              </a:spcAft>
+              <a:buClr>
+                <a:srgbClr val="595959"/>
+              </a:buClr>
+              <a:buSzPts val="900"/>
+              <a:buFont typeface="Arial"/>
+              <a:buChar char="•"/>
+            </a:pPr>
+            <a:r>
+              <a:rPr lang="fr-FR" i="0" u="none" dirty="0">
+                <a:solidFill>
+                  <a:srgbClr val="595959"/>
+                </a:solidFill>
+              </a:rPr>
+              <a:t>Y aura-t-il un projecteur ?</a:t>
+            </a:r>
+            <a:endParaRPr lang="fr-FR" u="none" dirty="0"/>
+          </a:p>
+          <a:p>
+            <a:pPr marL="1085850" lvl="2" indent="-171450" algn="l" rtl="0">
+              <a:spcBef>
+                <a:spcPts val="0"/>
+              </a:spcBef>
+              <a:spcAft>
+                <a:spcPts val="0"/>
+              </a:spcAft>
+              <a:buClr>
+                <a:srgbClr val="595959"/>
+              </a:buClr>
+              <a:buSzPts val="900"/>
+              <a:buFont typeface="Arial"/>
+              <a:buChar char="•"/>
+            </a:pPr>
+            <a:r>
+              <a:rPr lang="fr-FR" i="0" u="none" dirty="0">
+                <a:solidFill>
+                  <a:srgbClr val="595959"/>
+                </a:solidFill>
+              </a:rPr>
+              <a:t>Si oui, quelle est la connectique (VGA, HDMI, etc.) et le(s) PC des </a:t>
+            </a:r>
+            <a:r>
+              <a:rPr lang="fr-FR" i="0" u="none" dirty="0" err="1">
+                <a:solidFill>
+                  <a:srgbClr val="595959"/>
+                </a:solidFill>
+              </a:rPr>
+              <a:t>Shifters</a:t>
+            </a:r>
+            <a:r>
+              <a:rPr lang="fr-FR" i="0" u="none" dirty="0">
+                <a:solidFill>
+                  <a:srgbClr val="595959"/>
+                </a:solidFill>
+              </a:rPr>
+              <a:t> est-il compatible ?</a:t>
+            </a:r>
+            <a:endParaRPr lang="fr-FR" u="none" dirty="0"/>
+          </a:p>
+          <a:p>
+            <a:pPr marL="1085850" lvl="2" indent="-171450" algn="l" rtl="0">
+              <a:spcBef>
+                <a:spcPts val="0"/>
+              </a:spcBef>
+              <a:spcAft>
+                <a:spcPts val="0"/>
+              </a:spcAft>
+              <a:buClr>
+                <a:srgbClr val="595959"/>
+              </a:buClr>
+              <a:buSzPts val="900"/>
+              <a:buFont typeface="Arial"/>
+              <a:buChar char="•"/>
+            </a:pPr>
+            <a:r>
+              <a:rPr lang="fr-FR" i="0" u="none" dirty="0">
+                <a:solidFill>
+                  <a:srgbClr val="595959"/>
+                </a:solidFill>
+              </a:rPr>
+              <a:t>Où sera situé le projecteur et, surtout, le PC des </a:t>
+            </a:r>
+            <a:r>
+              <a:rPr lang="fr-FR" i="0" u="none" dirty="0" err="1">
+                <a:solidFill>
+                  <a:srgbClr val="595959"/>
+                </a:solidFill>
+              </a:rPr>
+              <a:t>Shifters</a:t>
+            </a:r>
+            <a:r>
+              <a:rPr lang="fr-FR" i="0" u="none" dirty="0">
+                <a:solidFill>
+                  <a:srgbClr val="595959"/>
+                </a:solidFill>
+              </a:rPr>
+              <a:t> qui lui sera relié (c’est sur le PC qu’est connecté l’éventuel pointeur)</a:t>
+            </a:r>
+            <a:endParaRPr lang="fr-FR" u="none" dirty="0"/>
+          </a:p>
+          <a:p>
+            <a:pPr marL="628650" lvl="1" indent="-171450" algn="l" rtl="0">
+              <a:spcBef>
+                <a:spcPts val="0"/>
+              </a:spcBef>
+              <a:spcAft>
+                <a:spcPts val="0"/>
+              </a:spcAft>
+              <a:buClr>
+                <a:srgbClr val="595959"/>
+              </a:buClr>
+              <a:buSzPts val="900"/>
+              <a:buFont typeface="Arial"/>
+              <a:buChar char="•"/>
+            </a:pPr>
+            <a:r>
+              <a:rPr lang="fr-FR" i="0" u="none" dirty="0">
+                <a:solidFill>
+                  <a:srgbClr val="595959"/>
+                </a:solidFill>
+              </a:rPr>
+              <a:t>Captation: les organisateurs / les </a:t>
+            </a:r>
+            <a:r>
+              <a:rPr lang="fr-FR" i="0" u="none" dirty="0" err="1">
+                <a:solidFill>
+                  <a:srgbClr val="595959"/>
+                </a:solidFill>
+              </a:rPr>
+              <a:t>Shifters</a:t>
+            </a:r>
+            <a:r>
+              <a:rPr lang="fr-FR" i="0" u="none" dirty="0">
+                <a:solidFill>
+                  <a:srgbClr val="595959"/>
+                </a:solidFill>
+              </a:rPr>
+              <a:t> prévoient-ils une captation ? Si oui : </a:t>
+            </a:r>
+            <a:endParaRPr lang="fr-FR" u="none" dirty="0"/>
+          </a:p>
+          <a:p>
+            <a:pPr marL="1085850" lvl="2" indent="-171450" algn="l" rtl="0">
+              <a:spcBef>
+                <a:spcPts val="0"/>
+              </a:spcBef>
+              <a:spcAft>
+                <a:spcPts val="0"/>
+              </a:spcAft>
+              <a:buClr>
+                <a:srgbClr val="595959"/>
+              </a:buClr>
+              <a:buSzPts val="900"/>
+              <a:buFont typeface="Arial"/>
+              <a:buChar char="•"/>
+            </a:pPr>
+            <a:r>
+              <a:rPr lang="fr-FR" i="0" u="none" dirty="0">
+                <a:solidFill>
+                  <a:srgbClr val="595959"/>
+                </a:solidFill>
+              </a:rPr>
+              <a:t>Pour la vidéo, faire un test de cadrage (les conférenciers se déplacent souvent), et s’assurer que les conditions de luminosité seront convenables. </a:t>
+            </a:r>
+            <a:endParaRPr lang="fr-FR" u="none" dirty="0"/>
+          </a:p>
+          <a:p>
+            <a:pPr marL="1085850" lvl="2" indent="-171450" algn="l" rtl="0">
+              <a:spcBef>
+                <a:spcPts val="0"/>
+              </a:spcBef>
+              <a:spcAft>
+                <a:spcPts val="0"/>
+              </a:spcAft>
+              <a:buClr>
+                <a:srgbClr val="595959"/>
+              </a:buClr>
+              <a:buSzPts val="900"/>
+              <a:buFont typeface="Arial"/>
+              <a:buChar char="•"/>
+            </a:pPr>
+            <a:r>
+              <a:rPr lang="fr-FR" i="0" u="none" dirty="0">
+                <a:solidFill>
+                  <a:srgbClr val="595959"/>
+                </a:solidFill>
+              </a:rPr>
+              <a:t>Pour le son, la difficulté est souvent d’avoir un son clair des conférenciers, surtout si la captation son est faite par la caméra (qui est généralement située loin d’eux), et de réussir à capter les questions/interventions du public. S’il y a des micros à disposition (pour les conférenciers et/ou le public), ces micros sont-ils également reliés à une sono dans la salle, ou ne servent-ils qu’à enregistrer ?</a:t>
+            </a:r>
+            <a:endParaRPr lang="fr-FR" u="none" dirty="0"/>
+          </a:p>
+          <a:p>
+            <a:pPr marL="628650" lvl="1" indent="-171450" algn="l" rtl="0">
+              <a:spcBef>
+                <a:spcPts val="0"/>
+              </a:spcBef>
+              <a:spcAft>
+                <a:spcPts val="0"/>
+              </a:spcAft>
+              <a:buClr>
+                <a:srgbClr val="595959"/>
+              </a:buClr>
+              <a:buSzPts val="900"/>
+              <a:buFont typeface="Arial"/>
+              <a:buChar char="•"/>
+            </a:pPr>
+            <a:r>
+              <a:rPr lang="fr-FR" i="0" u="none" dirty="0">
+                <a:solidFill>
+                  <a:srgbClr val="595959"/>
+                </a:solidFill>
+              </a:rPr>
+              <a:t>Communication sur place:</a:t>
+            </a:r>
+            <a:endParaRPr lang="fr-FR" u="none" dirty="0"/>
+          </a:p>
+          <a:p>
+            <a:pPr marL="1085850" lvl="2" indent="-171450" algn="l" rtl="0">
+              <a:spcBef>
+                <a:spcPts val="0"/>
+              </a:spcBef>
+              <a:spcAft>
+                <a:spcPts val="0"/>
+              </a:spcAft>
+              <a:buClr>
+                <a:srgbClr val="595959"/>
+              </a:buClr>
+              <a:buSzPts val="900"/>
+              <a:buFont typeface="Arial"/>
+              <a:buChar char="•"/>
+            </a:pPr>
+            <a:r>
+              <a:rPr lang="fr-FR" i="0" u="none" dirty="0">
+                <a:solidFill>
+                  <a:srgbClr val="595959"/>
+                </a:solidFill>
+              </a:rPr>
+              <a:t>Envoyer un support de communication / affiche aux organisateurs pour qu’ils l’annoncent</a:t>
+            </a:r>
+            <a:endParaRPr lang="fr-FR" u="none" dirty="0"/>
+          </a:p>
+          <a:p>
+            <a:pPr marL="1085850" lvl="2" indent="-171450" algn="l" rtl="0">
+              <a:spcBef>
+                <a:spcPts val="0"/>
+              </a:spcBef>
+              <a:spcAft>
+                <a:spcPts val="0"/>
+              </a:spcAft>
+              <a:buClr>
+                <a:srgbClr val="595959"/>
+              </a:buClr>
+              <a:buSzPts val="900"/>
+              <a:buFont typeface="Arial"/>
+              <a:buChar char="•"/>
+            </a:pPr>
+            <a:r>
+              <a:rPr lang="fr-FR" i="0" u="none" dirty="0">
+                <a:solidFill>
+                  <a:srgbClr val="595959"/>
+                </a:solidFill>
+              </a:rPr>
+              <a:t>Demander qu’ils installent des affiches le jour de la conférence pour guider vers la salle où elle a lieu</a:t>
+            </a:r>
+            <a:endParaRPr lang="fr-FR" u="none" dirty="0"/>
+          </a:p>
+          <a:p>
+            <a:pPr marL="1085850" lvl="2" indent="-171450" algn="l" rtl="0">
+              <a:spcBef>
+                <a:spcPts val="0"/>
+              </a:spcBef>
+              <a:spcAft>
+                <a:spcPts val="0"/>
+              </a:spcAft>
+              <a:buClr>
+                <a:srgbClr val="595959"/>
+              </a:buClr>
+              <a:buSzPts val="900"/>
+              <a:buFont typeface="Arial"/>
+              <a:buChar char="•"/>
+            </a:pPr>
+            <a:r>
+              <a:rPr lang="fr-FR" i="0" u="none" dirty="0">
+                <a:solidFill>
+                  <a:srgbClr val="595959"/>
+                </a:solidFill>
+              </a:rPr>
+              <a:t>Apporter des documents avec lesquels le public peut repartir : exemplaires du Manifeste et/ou du livre Décarbonons à vendre, des calendrier des saisons fruits &amp; légumes, une synthèse des actions à mener (diapo à créer)</a:t>
+            </a:r>
+            <a:endParaRPr lang="fr-FR" u="none" dirty="0"/>
           </a:p>
         </p:txBody>
       </p:sp>
@@ -587,329 +1491,6 @@
   <p:clrMapOvr>
     <a:masterClrMapping/>
   </p:clrMapOvr>
-</p:sldLayout>
-</file>
-
-<file path=ppt/slideLayouts/slideLayout10.xml><?xml version="1.0" encoding="utf-8"?>
-<p:sldLayout xmlns:a="http://schemas.openxmlformats.org/drawingml/2006/main" xmlns:r="http://schemas.openxmlformats.org/officeDocument/2006/relationships" xmlns:p="http://schemas.openxmlformats.org/presentationml/2006/main" userDrawn="1">
-  <p:cSld name="Diapositive de titre bleu">
-    <p:bg>
-      <p:bgPr>
-        <a:solidFill>
-          <a:schemeClr val="bg2"/>
-        </a:solidFill>
-        <a:effectLst/>
-      </p:bgPr>
-    </p:bg>
-    <p:spTree>
-      <p:nvGrpSpPr>
-        <p:cNvPr id="1" name=""/>
-        <p:cNvGrpSpPr/>
-        <p:nvPr/>
-      </p:nvGrpSpPr>
-      <p:grpSpPr>
-        <a:xfrm>
-          <a:off x="0" y="0"/>
-          <a:ext cx="0" cy="0"/>
-          <a:chOff x="0" y="0"/>
-          <a:chExt cx="0" cy="0"/>
-        </a:xfrm>
-      </p:grpSpPr>
-      <p:sp>
-        <p:nvSpPr>
-          <p:cNvPr id="10" name="Rectangle 9">
-            <a:extLst>
-              <a:ext uri="{FF2B5EF4-FFF2-40B4-BE49-F238E27FC236}">
-                <a16:creationId xmlns:a16="http://schemas.microsoft.com/office/drawing/2014/main" id="{BB29DA17-B5FA-4948-8711-48CDB58AFCAE}"/>
-              </a:ext>
-            </a:extLst>
-          </p:cNvPr>
-          <p:cNvSpPr/>
-          <p:nvPr userDrawn="1"/>
-        </p:nvSpPr>
-        <p:spPr>
-          <a:xfrm>
-            <a:off x="5375274" y="0"/>
-            <a:ext cx="6816726" cy="6858000"/>
-          </a:xfrm>
-          <a:prstGeom prst="rect">
-            <a:avLst/>
-          </a:prstGeom>
-          <a:solidFill>
-            <a:schemeClr val="tx2"/>
-          </a:solidFill>
-          <a:ln>
-            <a:noFill/>
-          </a:ln>
-        </p:spPr>
-        <p:style>
-          <a:lnRef idx="2">
-            <a:schemeClr val="accent1">
-              <a:shade val="50000"/>
-            </a:schemeClr>
-          </a:lnRef>
-          <a:fillRef idx="1">
-            <a:schemeClr val="accent1"/>
-          </a:fillRef>
-          <a:effectRef idx="0">
-            <a:schemeClr val="accent1"/>
-          </a:effectRef>
-          <a:fontRef idx="minor">
-            <a:schemeClr val="lt1"/>
-          </a:fontRef>
-        </p:style>
-        <p:txBody>
-          <a:bodyPr rtlCol="0" anchor="ctr"/>
-          <a:lstStyle/>
-          <a:p>
-            <a:pPr algn="ctr"/>
-            <a:endParaRPr lang="fr-FR"/>
-          </a:p>
-        </p:txBody>
-      </p:sp>
-      <p:sp>
-        <p:nvSpPr>
-          <p:cNvPr id="9" name="Espace réservé du texte 3">
-            <a:extLst>
-              <a:ext uri="{FF2B5EF4-FFF2-40B4-BE49-F238E27FC236}">
-                <a16:creationId xmlns:a16="http://schemas.microsoft.com/office/drawing/2014/main" id="{3669946F-B2D5-4055-BCCE-FA4B82448FBE}"/>
-              </a:ext>
-            </a:extLst>
-          </p:cNvPr>
-          <p:cNvSpPr>
-            <a:spLocks noGrp="1"/>
-          </p:cNvSpPr>
-          <p:nvPr>
-            <p:ph type="body" sz="quarter" idx="10" hasCustomPrompt="1"/>
-          </p:nvPr>
-        </p:nvSpPr>
-        <p:spPr>
-          <a:xfrm>
-            <a:off x="695324" y="2184399"/>
-            <a:ext cx="3960814" cy="3584575"/>
-          </a:xfrm>
-          <a:prstGeom prst="rect">
-            <a:avLst/>
-          </a:prstGeom>
-        </p:spPr>
-        <p:txBody>
-          <a:bodyPr lIns="0" tIns="0" rIns="0" bIns="0" anchor="b"/>
-          <a:lstStyle>
-            <a:lvl1pPr marL="0" indent="0">
-              <a:lnSpc>
-                <a:spcPct val="90000"/>
-              </a:lnSpc>
-              <a:spcBef>
-                <a:spcPts val="0"/>
-              </a:spcBef>
-              <a:buNone/>
-              <a:defRPr sz="4000" b="1">
-                <a:solidFill>
-                  <a:schemeClr val="bg1"/>
-                </a:solidFill>
-              </a:defRPr>
-            </a:lvl1pPr>
-            <a:lvl2pPr marL="0" indent="0">
-              <a:lnSpc>
-                <a:spcPct val="90000"/>
-              </a:lnSpc>
-              <a:spcBef>
-                <a:spcPts val="0"/>
-              </a:spcBef>
-              <a:spcAft>
-                <a:spcPts val="600"/>
-              </a:spcAft>
-              <a:buNone/>
-              <a:defRPr sz="1800">
-                <a:solidFill>
-                  <a:schemeClr val="accent1"/>
-                </a:solidFill>
-              </a:defRPr>
-            </a:lvl2pPr>
-            <a:lvl3pPr marL="0" indent="0">
-              <a:lnSpc>
-                <a:spcPct val="100000"/>
-              </a:lnSpc>
-              <a:spcBef>
-                <a:spcPts val="0"/>
-              </a:spcBef>
-              <a:buNone/>
-              <a:tabLst/>
-              <a:defRPr sz="1200">
-                <a:solidFill>
-                  <a:schemeClr val="bg1"/>
-                </a:solidFill>
-              </a:defRPr>
-            </a:lvl3pPr>
-            <a:lvl4pPr marL="0" indent="0">
-              <a:lnSpc>
-                <a:spcPct val="100000"/>
-              </a:lnSpc>
-              <a:spcBef>
-                <a:spcPts val="0"/>
-              </a:spcBef>
-              <a:buNone/>
-              <a:defRPr sz="1200">
-                <a:solidFill>
-                  <a:schemeClr val="bg1"/>
-                </a:solidFill>
-              </a:defRPr>
-            </a:lvl4pPr>
-            <a:lvl5pPr>
-              <a:defRPr>
-                <a:solidFill>
-                  <a:schemeClr val="bg1"/>
-                </a:solidFill>
-              </a:defRPr>
-            </a:lvl5pPr>
-          </a:lstStyle>
-          <a:p>
-            <a:pPr lvl="0"/>
-            <a:r>
-              <a:rPr lang="fr-FR" dirty="0"/>
-              <a:t>Titre du document</a:t>
-            </a:r>
-          </a:p>
-          <a:p>
-            <a:pPr lvl="1"/>
-            <a:r>
-              <a:rPr lang="fr-FR" dirty="0"/>
-              <a:t>Sous titre</a:t>
-            </a:r>
-          </a:p>
-          <a:p>
-            <a:pPr lvl="2"/>
-            <a:r>
-              <a:rPr lang="fr-FR" dirty="0"/>
-              <a:t>Date</a:t>
-            </a:r>
-          </a:p>
-          <a:p>
-            <a:pPr lvl="2"/>
-            <a:endParaRPr lang="fr-FR" dirty="0"/>
-          </a:p>
-          <a:p>
-            <a:pPr lvl="3"/>
-            <a:r>
-              <a:rPr lang="fr-FR" dirty="0"/>
-              <a:t>Commentaire</a:t>
-            </a:r>
-          </a:p>
-        </p:txBody>
-      </p:sp>
-      <p:sp>
-        <p:nvSpPr>
-          <p:cNvPr id="3" name="Espace réservé pour une image  2">
-            <a:extLst>
-              <a:ext uri="{FF2B5EF4-FFF2-40B4-BE49-F238E27FC236}">
-                <a16:creationId xmlns:a16="http://schemas.microsoft.com/office/drawing/2014/main" id="{E185E597-E003-47B2-A9B9-5E102EB08CB9}"/>
-              </a:ext>
-            </a:extLst>
-          </p:cNvPr>
-          <p:cNvSpPr>
-            <a:spLocks noGrp="1"/>
-          </p:cNvSpPr>
-          <p:nvPr>
-            <p:ph type="pic" sz="quarter" idx="11" hasCustomPrompt="1"/>
-          </p:nvPr>
-        </p:nvSpPr>
-        <p:spPr>
-          <a:xfrm>
-            <a:off x="5375274" y="0"/>
-            <a:ext cx="6816726" cy="6858000"/>
-          </a:xfrm>
-          <a:prstGeom prst="rect">
-            <a:avLst/>
-          </a:prstGeom>
-        </p:spPr>
-        <p:txBody>
-          <a:bodyPr anchor="ctr" anchorCtr="0"/>
-          <a:lstStyle>
-            <a:lvl1pPr marL="0" indent="0" algn="ctr">
-              <a:buNone/>
-              <a:defRPr>
-                <a:solidFill>
-                  <a:schemeClr val="bg2">
-                    <a:lumMod val="60000"/>
-                    <a:lumOff val="40000"/>
-                  </a:schemeClr>
-                </a:solidFill>
-              </a:defRPr>
-            </a:lvl1pPr>
-          </a:lstStyle>
-          <a:p>
-            <a:r>
-              <a:rPr lang="fr-FR" dirty="0"/>
-              <a:t>Image</a:t>
-            </a:r>
-          </a:p>
-        </p:txBody>
-      </p:sp>
-      <p:pic>
-        <p:nvPicPr>
-          <p:cNvPr id="11" name="Graphique 10">
-            <a:extLst>
-              <a:ext uri="{FF2B5EF4-FFF2-40B4-BE49-F238E27FC236}">
-                <a16:creationId xmlns:a16="http://schemas.microsoft.com/office/drawing/2014/main" id="{97794603-8F19-4589-8469-8ED82851F7B7}"/>
-              </a:ext>
-            </a:extLst>
-          </p:cNvPr>
-          <p:cNvPicPr>
-            <a:picLocks noChangeAspect="1"/>
-          </p:cNvPicPr>
-          <p:nvPr userDrawn="1"/>
-        </p:nvPicPr>
-        <p:blipFill>
-          <a:blip r:embed="rId2" cstate="hqprint">
-            <a:extLst>
-              <a:ext uri="{28A0092B-C50C-407E-A947-70E740481C1C}">
-                <a14:useLocalDpi xmlns:a14="http://schemas.microsoft.com/office/drawing/2010/main" val="0"/>
-              </a:ext>
-              <a:ext uri="{96DAC541-7B7A-43D3-8B79-37D633B846F1}">
-                <asvg:svgBlip xmlns:asvg="http://schemas.microsoft.com/office/drawing/2016/SVG/main" r:embed="rId3"/>
-              </a:ext>
-            </a:extLst>
-          </a:blip>
-          <a:stretch>
-            <a:fillRect/>
-          </a:stretch>
-        </p:blipFill>
-        <p:spPr>
-          <a:xfrm>
-            <a:off x="695325" y="728663"/>
-            <a:ext cx="1080000" cy="544954"/>
-          </a:xfrm>
-          <a:prstGeom prst="rect">
-            <a:avLst/>
-          </a:prstGeom>
-        </p:spPr>
-      </p:pic>
-    </p:spTree>
-    <p:extLst>
-      <p:ext uri="{BB962C8B-B14F-4D97-AF65-F5344CB8AC3E}">
-        <p14:creationId xmlns:p14="http://schemas.microsoft.com/office/powerpoint/2010/main" val="4150271135"/>
-      </p:ext>
-    </p:extLst>
-  </p:cSld>
-  <p:clrMapOvr>
-    <a:masterClrMapping/>
-  </p:clrMapOvr>
-  <p:extLst>
-    <p:ext uri="{DCECCB84-F9BA-43D5-87BE-67443E8EF086}">
-      <p15:sldGuideLst xmlns:p15="http://schemas.microsoft.com/office/powerpoint/2012/main">
-        <p15:guide id="1" pos="2933">
-          <p15:clr>
-            <a:srgbClr val="FBAE40"/>
-          </p15:clr>
-        </p15:guide>
-        <p15:guide id="2" orient="horz" pos="3634">
-          <p15:clr>
-            <a:srgbClr val="FBAE40"/>
-          </p15:clr>
-        </p15:guide>
-      </p15:sldGuideLst>
-    </p:ext>
-  </p:extLst>
 </p:sldLayout>
 </file>
 
@@ -2957,7 +3538,6 @@
     <p:sldLayoutId id="2147483749" r:id="rId7"/>
     <p:sldLayoutId id="2147483750" r:id="rId8"/>
     <p:sldLayoutId id="2147483751" r:id="rId9"/>
-    <p:sldLayoutId id="2147483753" r:id="rId10"/>
   </p:sldLayoutIdLst>
   <p:hf hdr="0" ftr="0" dt="0"/>
   <p:txStyles>

</xml_diff>